<commit_message>
Manual locks on the payload bay
</commit_message>
<xml_diff>
--- a/Corporate/Roadmap_260813.pptx
+++ b/Corporate/Roadmap_260813.pptx
@@ -217,7 +217,7 @@
           <a:p>
             <a:fld id="{A32988D8-7AE2-42CB-A0B4-FCC6887E52AB}" type="datetimeFigureOut">
               <a:rPr lang="en-US" smtClean="0"/>
-              <a:t>8/13/2026</a:t>
+              <a:t>8/15/2026</a:t>
             </a:fld>
             <a:endParaRPr lang="en-US" dirty="0"/>
           </a:p>
@@ -394,7 +394,7 @@
           <a:p>
             <a:fld id="{6A99631F-07A9-4103-961D-4FC63F6313FA}" type="datetimeFigureOut">
               <a:rPr lang="en-US" smtClean="0"/>
-              <a:t>8/13/2026</a:t>
+              <a:t>8/15/2026</a:t>
             </a:fld>
             <a:endParaRPr lang="en-US" dirty="0"/>
           </a:p>
@@ -2373,25 +2373,8 @@
                       </a:schemeClr>
                     </a:solidFill>
                   </a:rPr>
-                  <a:t>P01 Technology </a:t>
+                  <a:t>P01 Technology Demonstrator</a:t>
                 </a:r>
-                <a:r>
-                  <a:rPr lang="en-US" sz="1200" dirty="0" err="1">
-                    <a:solidFill>
-                      <a:schemeClr val="bg1">
-                        <a:lumMod val="85000"/>
-                      </a:schemeClr>
-                    </a:solidFill>
-                  </a:rPr>
-                  <a:t>Demonstator</a:t>
-                </a:r>
-                <a:endParaRPr lang="en-US" sz="1200" dirty="0">
-                  <a:solidFill>
-                    <a:schemeClr val="bg1">
-                      <a:lumMod val="85000"/>
-                    </a:schemeClr>
-                  </a:solidFill>
-                </a:endParaRPr>
               </a:p>
               <a:p>
                 <a:r>
@@ -5726,17 +5709,7 @@
                       </a:schemeClr>
                     </a:solidFill>
                   </a:rPr>
-                  <a:t>L01 Large ORGOfly Aircraft </a:t>
-                </a:r>
-                <a:r>
-                  <a:rPr lang="en-US" sz="1200" dirty="0" err="1">
-                    <a:solidFill>
-                      <a:schemeClr val="bg1">
-                        <a:lumMod val="85000"/>
-                      </a:schemeClr>
-                    </a:solidFill>
-                  </a:rPr>
-                  <a:t>programme</a:t>
+                  <a:t>L01 Large ORGOfly Aircraft program</a:t>
                 </a:r>
                 <a:br>
                   <a:rPr lang="en-US" sz="1400" dirty="0">

</xml_diff>